<commit_message>
Rebuild user manual deck for the new ingestion panel
Co-Authored-By: Claude Fable 5.1 <noreply@anthropic.com>
</commit_message>
<xml_diff>
--- a/docs/slides/bankrag-user-manual.pptx
+++ b/docs/slides/bankrag-user-manual.pptx
@@ -24401,7 +24401,7 @@
           <a:p>
             <a:pPr/>
             <a:r>
-              <a:t>The answer says 'no information in the knowledge base'</a:t>
+              <a:t>The answer says it has no details on a topic yet</a:t>
             </a:r>
           </a:p>
           <a:p>
@@ -26308,7 +26308,7 @@
                 </a:solidFill>
                 <a:latin typeface="BBL Sans Office Medium"/>
               </a:rPr>
-              <a:t>Every long action (sync, ingest, crawl, eval) runs as a job with a live log at the bottom of the tab. Changes to skills reach the assistant only after 'Save &amp; sync'.</a:t>
+              <a:t>Every long action (sync, ingest, crawl, eval) runs as a job. The Knowledge tab shows it in the Ingestion panel: phase stepper, progress bar, counters, log and recent runs. Changes to skills reach the assistant only after 'Save &amp; sync'.</a:t>
             </a:r>
           </a:p>
         </p:txBody>
@@ -27645,7 +27645,7 @@
                 </a:solidFill>
                 <a:latin typeface="BBL Sans Office"/>
               </a:rPr>
-              <a:t>Only new or changed files are chunked and embedded. The log shows counts; the table shows chunks per file.</a:t>
+              <a:t>Only new or changed files are chunked and embedded. The Ingestion panel shows Scan, Embed, Upload progress with counts; the table shows chunks per file.</a:t>
             </a:r>
           </a:p>
         </p:txBody>

</xml_diff>

<commit_message>
docs: manual deck reflects the new Skills tab
Co-Authored-By: Claude Fable 5.1 <noreply@anthropic.com>
</commit_message>
<xml_diff>
--- a/docs/slides/bankrag-user-manual.pptx
+++ b/docs/slides/bankrag-user-manual.pptx
@@ -26594,7 +26594,7 @@
                 </a:solidFill>
                 <a:latin typeface="BBL Sans Office"/>
               </a:rPr>
-              <a:t>Click a row. Lint findings show at the top of the editor (keyword overlap, missing Thai/English follow-ups, model not deployed).</a:t>
+              <a:t>Click a skill card (dot = Foundry state: in sync, outdated, not deployed). Lint findings sit above the instructions (keyword overlap, missing Thai/English follow-ups, model not deployed).</a:t>
             </a:r>
           </a:p>
         </p:txBody>
@@ -26694,7 +26694,7 @@
                 </a:solidFill>
                 <a:latin typeface="BBL Sans Office"/>
               </a:rPr>
-              <a:t>Form on the left, markdown instructions on the right. Cmd/Ctrl+S saves; an 'unsaved' badge warns before you leave.</a:t>
+              <a:t>Routing and answering settings on the left, markdown instructions on the right. Cmd/Ctrl+S saves; an 'unsaved' badge warns before you leave.</a:t>
             </a:r>
           </a:p>
         </p:txBody>
@@ -26794,7 +26794,7 @@
                 </a:solidFill>
                 <a:latin typeface="BBL Sans Office"/>
               </a:rPr>
-              <a:t>Creates a new agent version in Foundry and shows 'version N -&gt; N+1'. 'Save' alone only writes the file.</a:t>
+              <a:t>Creates a new agent version in Foundry; the Foundry sync panel shows progress per skill and the result rows. 'Save' alone only writes the file.</a:t>
             </a:r>
           </a:p>
         </p:txBody>

</xml_diff>

<commit_message>
Studio: redesign Evals tab with xlsx export
Structured progress for routing, grounded and comparison runs; result
panels with KPI cards, pass bar and failed-only filter; run history with
trend, per-run and full-history .xlsx export (openpyxl) and run deletion.

Co-Authored-By: Claude Fable 5.1 <noreply@anthropic.com>
</commit_message>
<xml_diff>
--- a/docs/slides/bankrag-user-manual.pptx
+++ b/docs/slides/bankrag-user-manual.pptx
@@ -28116,7 +28116,13 @@
           <a:p>
             <a:pPr lvl="1"/>
             <a:r>
-              <a:t>Run history keeps every result for comparison</a:t>
+              <a:t>The Eval run panel shows progress with pass/fail counts; the result opens with KPI cards and a failed-only filter</a:t>
+            </a:r>
+          </a:p>
+          <a:p>
+            <a:pPr lvl="1"/>
+            <a:r>
+              <a:t>Export .xlsx per run, or 'Export all' for every stored run (one sheet each); run history shows a trend</a:t>
             </a:r>
           </a:p>
         </p:txBody>

</xml_diff>

<commit_message>
Evals: DeepEval quality metrics with a Foundry LLM-as-judge
New Quality (DeepEval) set: the pipeline answers each question, then a
judge deployment scores faithfulness, answer/contextual relevancy,
contextual precision/recall, tool correctness, task completion and two
G-Eval rubrics (language & tone, no personal advice). Full retrieval
context is captured from the knowledge-base tool output for the judge.
Results render with per-metric score chips and export to xlsx. Pins
httpx<1 (deepeval pulled a 1.0 dev build). Base rules: citations are
links only, never a sentence about where facts come from.

Co-Authored-By: Claude Fable 5.1 <noreply@anthropic.com>
</commit_message>
<xml_diff>
--- a/docs/slides/bankrag-user-manual.pptx
+++ b/docs/slides/bankrag-user-manual.pptx
@@ -28144,31 +28144,31 @@
           <a:p>
             <a:pPr/>
             <a:r>
-              <a:t>Model comparison</a:t>
+              <a:t>Quality (DeepEval) and model comparison</a:t>
             </a:r>
           </a:p>
           <a:p>
             <a:pPr lvl="1"/>
             <a:r>
-              <a:t>Pick a skill, two or three models and a few questions</a:t>
+              <a:t>Quality: a judge model (your Foundry deployment) scores each answer on RAG metrics (faithfulness, relevancy, context) and agentic metrics (tool use, task completion, language &amp; tone, no advice)</a:t>
             </a:r>
           </a:p>
           <a:p>
             <a:pPr lvl="1"/>
             <a:r>
-              <a:t>Temporary agents are created per model and deleted after the run</a:t>
+              <a:t>Hover a score for the judge's reason; tune the threshold and the metric set; export .xlsx</a:t>
             </a:r>
           </a:p>
           <a:p>
             <a:pPr lvl="1"/>
             <a:r>
+              <a:t>Comparison: pick a skill, two or three models and a few questions; temporary agents are deleted after the run</a:t>
+            </a:r>
+          </a:p>
+          <a:p>
+            <a:pPr lvl="1"/>
+            <a:r>
               <a:t>Side-by-side answers with latency, tokens and cost per model</a:t>
-            </a:r>
-          </a:p>
-          <a:p>
-            <a:pPr lvl="1"/>
-            <a:r>
-              <a:t>Use it to justify a model change before editing the skill</a:t>
             </a:r>
           </a:p>
         </p:txBody>

</xml_diff>

<commit_message>
Studio: redesign Conversations tab with a selection box
Flat question list with search and filters, per-question checkboxes in
the list and in the transcript, a selection box that exports the chosen
questions to xlsx or appends them to the routing, grounded or quality
eval set (duplicates skipped).

Co-Authored-By: Claude Fable 5.1 <noreply@anthropic.com>
</commit_message>
<xml_diff>
--- a/docs/slides/bankrag-user-manual.pptx
+++ b/docs/slides/bankrag-user-manual.pptx
@@ -23887,25 +23887,31 @@
           <a:p>
             <a:pPr/>
             <a:r>
-              <a:t>List</a:t>
+              <a:t>Questions and selection box</a:t>
             </a:r>
           </a:p>
           <a:p>
             <a:pPr lvl="1"/>
             <a:r>
-              <a:t>Filter by skill or rating; see turns, cost and 👍/👎 counts per conversation</a:t>
+              <a:t>Search question or answer text; filter by skill, rating and source; every customer question is one row</a:t>
             </a:r>
           </a:p>
           <a:p>
             <a:pPr lvl="1"/>
             <a:r>
-              <a:t>Delete a conversation you no longer need</a:t>
+              <a:t>Tick questions (or 'select all shown', or all questions of one conversation) to fill the selection box</a:t>
             </a:r>
           </a:p>
           <a:p>
             <a:pPr lvl="1"/>
             <a:r>
-              <a:t>'Export feedback CSV' downloads all ratings with question, answer, skill and cost</a:t>
+              <a:t>Export the box to .xlsx (question, answer, skill, rating, comment, cost, latency)</a:t>
+            </a:r>
+          </a:p>
+          <a:p>
+            <a:pPr lvl="1"/>
+            <a:r>
+              <a:t>Send the box to the Routing, Grounded or Quality eval set; duplicates are skipped</a:t>
             </a:r>
           </a:p>
         </p:txBody>
@@ -23927,7 +23933,7 @@
           <a:p>
             <a:pPr/>
             <a:r>
-              <a:t>Transcript</a:t>
+              <a:t>Transcript and feedback</a:t>
             </a:r>
           </a:p>
           <a:p>
@@ -23945,7 +23951,7 @@
           <a:p>
             <a:pPr lvl="1"/>
             <a:r>
-              <a:t>Ratings given in the customer app appear here too</a:t>
+              <a:t>Ratings given in the customer app appear here too; 'Feedback CSV' exports them all</a:t>
             </a:r>
           </a:p>
         </p:txBody>

</xml_diff>

<commit_message>
Studio: usable bundle export/import; xlsx upload for eval question sets
Export picks parts and can leave PDFs out; import previews new/changed
files, imports chosen parts, then ingests changed categories and syncs
skills as one job. Eval sets download as .xlsx and accept .xlsx/.csv
uploads (append with duplicate skip, or replace). Fixes the Evals
question tables, which the Conversations script had overridden through
a same-named global function.

Co-Authored-By: Claude Fable 5.1 <noreply@anthropic.com>
</commit_message>
<xml_diff>
--- a/docs/slides/bankrag-user-manual.pptx
+++ b/docs/slides/bankrag-user-manual.pptx
@@ -28168,6 +28168,12 @@
           <a:p>
             <a:pPr lvl="1"/>
             <a:r>
+              <a:t>Question sets: download as .xlsx (also the template) and upload an .xlsx or CSV to append or replace; or send questions from the Conversations tab</a:t>
+            </a:r>
+          </a:p>
+          <a:p>
+            <a:pPr lvl="1"/>
+            <a:r>
               <a:t>Comparison: pick a skill, two or three models and a few questions; temporary agents are deleted after the run</a:t>
             </a:r>
           </a:p>

</xml_diff>